<commit_message>
updated some error in pauls 2nd,3rd headings
</commit_message>
<xml_diff>
--- a/church/church ppts/sermon/2nd missionary journey/pauls2nd.pptx
+++ b/church/church ppts/sermon/2nd missionary journey/pauls2nd.pptx
@@ -299,7 +299,7 @@
           <a:p>
             <a:fld id="{BC695041-2FC5-4DA0-9DD8-242C72FB0FA9}" type="datetimeFigureOut">
               <a:rPr lang="en-IN" smtClean="0"/>
-              <a:t>24-05-2026</a:t>
+              <a:t>18-07-2026</a:t>
             </a:fld>
             <a:endParaRPr lang="en-IN"/>
           </a:p>
@@ -574,7 +574,7 @@
           <a:p>
             <a:fld id="{BC695041-2FC5-4DA0-9DD8-242C72FB0FA9}" type="datetimeFigureOut">
               <a:rPr lang="en-IN" smtClean="0"/>
-              <a:t>24-05-2026</a:t>
+              <a:t>18-07-2026</a:t>
             </a:fld>
             <a:endParaRPr lang="en-IN"/>
           </a:p>
@@ -768,7 +768,7 @@
           <a:p>
             <a:fld id="{BC695041-2FC5-4DA0-9DD8-242C72FB0FA9}" type="datetimeFigureOut">
               <a:rPr lang="en-IN" smtClean="0"/>
-              <a:t>24-05-2026</a:t>
+              <a:t>18-07-2026</a:t>
             </a:fld>
             <a:endParaRPr lang="en-IN"/>
           </a:p>
@@ -1041,7 +1041,7 @@
           <a:p>
             <a:fld id="{BC695041-2FC5-4DA0-9DD8-242C72FB0FA9}" type="datetimeFigureOut">
               <a:rPr lang="en-IN" smtClean="0"/>
-              <a:t>24-05-2026</a:t>
+              <a:t>18-07-2026</a:t>
             </a:fld>
             <a:endParaRPr lang="en-IN"/>
           </a:p>
@@ -1382,7 +1382,7 @@
           <a:p>
             <a:fld id="{BC695041-2FC5-4DA0-9DD8-242C72FB0FA9}" type="datetimeFigureOut">
               <a:rPr lang="en-IN" smtClean="0"/>
-              <a:t>24-05-2026</a:t>
+              <a:t>18-07-2026</a:t>
             </a:fld>
             <a:endParaRPr lang="en-IN"/>
           </a:p>
@@ -2005,7 +2005,7 @@
           <a:p>
             <a:fld id="{BC695041-2FC5-4DA0-9DD8-242C72FB0FA9}" type="datetimeFigureOut">
               <a:rPr lang="en-IN" smtClean="0"/>
-              <a:t>24-05-2026</a:t>
+              <a:t>18-07-2026</a:t>
             </a:fld>
             <a:endParaRPr lang="en-IN"/>
           </a:p>
@@ -2865,7 +2865,7 @@
           <a:p>
             <a:fld id="{BC695041-2FC5-4DA0-9DD8-242C72FB0FA9}" type="datetimeFigureOut">
               <a:rPr lang="en-IN" smtClean="0"/>
-              <a:t>24-05-2026</a:t>
+              <a:t>18-07-2026</a:t>
             </a:fld>
             <a:endParaRPr lang="en-IN"/>
           </a:p>
@@ -3035,7 +3035,7 @@
           <a:p>
             <a:fld id="{BC695041-2FC5-4DA0-9DD8-242C72FB0FA9}" type="datetimeFigureOut">
               <a:rPr lang="en-IN" smtClean="0"/>
-              <a:t>24-05-2026</a:t>
+              <a:t>18-07-2026</a:t>
             </a:fld>
             <a:endParaRPr lang="en-IN"/>
           </a:p>
@@ -3215,7 +3215,7 @@
           <a:p>
             <a:fld id="{BC695041-2FC5-4DA0-9DD8-242C72FB0FA9}" type="datetimeFigureOut">
               <a:rPr lang="en-IN" smtClean="0"/>
-              <a:t>24-05-2026</a:t>
+              <a:t>18-07-2026</a:t>
             </a:fld>
             <a:endParaRPr lang="en-IN"/>
           </a:p>
@@ -3385,7 +3385,7 @@
           <a:p>
             <a:fld id="{BC695041-2FC5-4DA0-9DD8-242C72FB0FA9}" type="datetimeFigureOut">
               <a:rPr lang="en-IN" smtClean="0"/>
-              <a:t>24-05-2026</a:t>
+              <a:t>18-07-2026</a:t>
             </a:fld>
             <a:endParaRPr lang="en-IN"/>
           </a:p>
@@ -3632,7 +3632,7 @@
           <a:p>
             <a:fld id="{BC695041-2FC5-4DA0-9DD8-242C72FB0FA9}" type="datetimeFigureOut">
               <a:rPr lang="en-IN" smtClean="0"/>
-              <a:t>24-05-2026</a:t>
+              <a:t>18-07-2026</a:t>
             </a:fld>
             <a:endParaRPr lang="en-IN"/>
           </a:p>
@@ -3924,7 +3924,7 @@
           <a:p>
             <a:fld id="{BC695041-2FC5-4DA0-9DD8-242C72FB0FA9}" type="datetimeFigureOut">
               <a:rPr lang="en-IN" smtClean="0"/>
-              <a:t>24-05-2026</a:t>
+              <a:t>18-07-2026</a:t>
             </a:fld>
             <a:endParaRPr lang="en-IN"/>
           </a:p>
@@ -4368,7 +4368,7 @@
           <a:p>
             <a:fld id="{BC695041-2FC5-4DA0-9DD8-242C72FB0FA9}" type="datetimeFigureOut">
               <a:rPr lang="en-IN" smtClean="0"/>
-              <a:t>24-05-2026</a:t>
+              <a:t>18-07-2026</a:t>
             </a:fld>
             <a:endParaRPr lang="en-IN"/>
           </a:p>
@@ -4486,7 +4486,7 @@
           <a:p>
             <a:fld id="{BC695041-2FC5-4DA0-9DD8-242C72FB0FA9}" type="datetimeFigureOut">
               <a:rPr lang="en-IN" smtClean="0"/>
-              <a:t>24-05-2026</a:t>
+              <a:t>18-07-2026</a:t>
             </a:fld>
             <a:endParaRPr lang="en-IN"/>
           </a:p>
@@ -4581,7 +4581,7 @@
           <a:p>
             <a:fld id="{BC695041-2FC5-4DA0-9DD8-242C72FB0FA9}" type="datetimeFigureOut">
               <a:rPr lang="en-IN" smtClean="0"/>
-              <a:t>24-05-2026</a:t>
+              <a:t>18-07-2026</a:t>
             </a:fld>
             <a:endParaRPr lang="en-IN"/>
           </a:p>
@@ -4860,7 +4860,7 @@
           <a:p>
             <a:fld id="{BC695041-2FC5-4DA0-9DD8-242C72FB0FA9}" type="datetimeFigureOut">
               <a:rPr lang="en-IN" smtClean="0"/>
-              <a:t>24-05-2026</a:t>
+              <a:t>18-07-2026</a:t>
             </a:fld>
             <a:endParaRPr lang="en-IN"/>
           </a:p>
@@ -5135,7 +5135,7 @@
           <a:p>
             <a:fld id="{BC695041-2FC5-4DA0-9DD8-242C72FB0FA9}" type="datetimeFigureOut">
               <a:rPr lang="en-IN" smtClean="0"/>
-              <a:t>24-05-2026</a:t>
+              <a:t>18-07-2026</a:t>
             </a:fld>
             <a:endParaRPr lang="en-IN"/>
           </a:p>
@@ -5564,7 +5564,7 @@
           <a:p>
             <a:fld id="{BC695041-2FC5-4DA0-9DD8-242C72FB0FA9}" type="datetimeFigureOut">
               <a:rPr lang="en-IN" smtClean="0"/>
-              <a:t>24-05-2026</a:t>
+              <a:t>18-07-2026</a:t>
             </a:fld>
             <a:endParaRPr lang="en-IN"/>
           </a:p>
@@ -6109,11 +6109,15 @@
           <a:p>
             <a:r>
               <a:rPr lang="en-US" dirty="0"/>
-              <a:t>Paul’s second missionary journey (circa A.D. </a:t>
+              <a:t>Paul’s second </a:t>
             </a:r>
             <a:r>
-              <a:rPr lang="en-US" dirty="0" smtClean="0"/>
-              <a:t>49–51)</a:t>
+              <a:rPr lang="en-US"/>
+              <a:t>missionary </a:t>
+            </a:r>
+            <a:r>
+              <a:rPr lang="en-US" smtClean="0"/>
+              <a:t>journey</a:t>
             </a:r>
             <a:endParaRPr lang="en-IN" dirty="0"/>
           </a:p>

</xml_diff>